<commit_message>
Evidence slide: highlight Weili Tian and Yue Zhuo in Cell Stem Cell author line
Co-Authored-By: Claude Opus 5.5 <noreply@anthropic.com>
Claude-Session: https://claude.ai/code/session_01NTagjVHGZdXLvG9VCNzDRT
</commit_message>
<xml_diff>
--- a/slides/Vitoma_why_now_2pages_draft.pptx
+++ b/slides/Vitoma_why_now_2pages_draft.pptx
@@ -848,6 +848,110 @@
           </a:prstGeom>
         </p:spPr>
       </p:pic>
+      <p:sp>
+        <p:nvSpPr>
+          <p:cNvPr id="500" name="作者遮罩"/>
+          <p:cNvSpPr/>
+          <p:nvPr/>
+        </p:nvSpPr>
+        <p:spPr>
+          <a:xfrm>
+            <a:off x="2848356" y="1883664"/>
+            <a:ext cx="1600200" cy="178308"/>
+          </a:xfrm>
+          <a:prstGeom prst="rect">
+            <a:avLst/>
+          </a:prstGeom>
+          <a:solidFill>
+            <a:srgbClr val="FFFFFF"/>
+          </a:solidFill>
+          <a:ln>
+            <a:noFill/>
+          </a:ln>
+        </p:spPr>
+        <p:txBody>
+          <a:bodyPr wrap="square" lIns="15545" tIns="0" rIns="0" bIns="0" anchor="ctr">
+            <a:noAutofit/>
+          </a:bodyPr>
+          <a:lstStyle/>
+          <a:p>
+            <a:pPr>
+              <a:lnSpc>
+                <a:spcPct val="100000"/>
+              </a:lnSpc>
+              <a:buNone/>
+            </a:pPr>
+            <a:r>
+              <a:rPr lang="en-US" sz="600">
+                <a:solidFill>
+                  <a:srgbClr val="231F20"/>
+                </a:solidFill>
+                <a:latin typeface="Arial"/>
+                <a:cs typeface="Arial"/>
+              </a:rPr>
+              <a:t>Tianping Peng, ..., </a:t>
+            </a:r>
+            <a:r>
+              <a:rPr lang="en-US" sz="600" b="1">
+                <a:solidFill>
+                  <a:srgbClr val="0B6FB8"/>
+                </a:solidFill>
+                <a:latin typeface="Arial"/>
+                <a:cs typeface="Arial"/>
+              </a:rPr>
+              <a:t>Weili Tian</a:t>
+            </a:r>
+            <a:r>
+              <a:rPr lang="en-US" sz="600">
+                <a:solidFill>
+                  <a:srgbClr val="231F20"/>
+                </a:solidFill>
+                <a:latin typeface="Arial"/>
+                <a:cs typeface="Arial"/>
+              </a:rPr>
+              <a:t>, ..., </a:t>
+            </a:r>
+            <a:r>
+              <a:rPr lang="en-US" sz="600" b="1">
+                <a:solidFill>
+                  <a:srgbClr val="0B6FB8"/>
+                </a:solidFill>
+                <a:latin typeface="Arial"/>
+                <a:cs typeface="Arial"/>
+              </a:rPr>
+              <a:t>Yue Zhuo</a:t>
+            </a:r>
+            <a:r>
+              <a:rPr lang="en-US" sz="600">
+                <a:solidFill>
+                  <a:srgbClr val="231F20"/>
+                </a:solidFill>
+                <a:latin typeface="Arial"/>
+                <a:cs typeface="Arial"/>
+              </a:rPr>
+              <a:t>,</a:t>
+            </a:r>
+          </a:p>
+          <a:p>
+            <a:pPr>
+              <a:lnSpc>
+                <a:spcPct val="100000"/>
+              </a:lnSpc>
+              <a:buNone/>
+            </a:pPr>
+            <a:r>
+              <a:rPr lang="en-US" sz="600">
+                <a:solidFill>
+                  <a:srgbClr val="231F20"/>
+                </a:solidFill>
+                <a:latin typeface="Arial"/>
+                <a:cs typeface="Arial"/>
+              </a:rPr>
+              <a:t>..., Hai-Kun Liu, Ying Mao</a:t>
+            </a:r>
+          </a:p>
+        </p:txBody>
+      </p:sp>
       <p:sp>
         <p:nvSpPr>
           <p:cNvPr id="401" name="证据1说明"/>

</xml_diff>

<commit_message>
Evidence slide: balance author line across two rows
Co-Authored-By: Claude Opus 5.5 <noreply@anthropic.com>
Claude-Session: https://claude.ai/code/session_01NTagjVHGZdXLvG9VCNzDRT
</commit_message>
<xml_diff>
--- a/slides/Vitoma_why_now_2pages_draft.pptx
+++ b/slides/Vitoma_why_now_2pages_draft.pptx
@@ -909,26 +909,6 @@
                 <a:latin typeface="Arial"/>
                 <a:cs typeface="Arial"/>
               </a:rPr>
-              <a:t>, ..., </a:t>
-            </a:r>
-            <a:r>
-              <a:rPr lang="en-US" sz="600" b="1">
-                <a:solidFill>
-                  <a:srgbClr val="0B6FB8"/>
-                </a:solidFill>
-                <a:latin typeface="Arial"/>
-                <a:cs typeface="Arial"/>
-              </a:rPr>
-              <a:t>Yue Zhuo</a:t>
-            </a:r>
-            <a:r>
-              <a:rPr lang="en-US" sz="600">
-                <a:solidFill>
-                  <a:srgbClr val="231F20"/>
-                </a:solidFill>
-                <a:latin typeface="Arial"/>
-                <a:cs typeface="Arial"/>
-              </a:rPr>
               <a:t>,</a:t>
             </a:r>
           </a:p>
@@ -947,7 +927,27 @@
                 <a:latin typeface="Arial"/>
                 <a:cs typeface="Arial"/>
               </a:rPr>
-              <a:t>...</a:t>
+              <a:t>..., </a:t>
+            </a:r>
+            <a:r>
+              <a:rPr lang="en-US" sz="600" b="1">
+                <a:solidFill>
+                  <a:srgbClr val="0B6FB8"/>
+                </a:solidFill>
+                <a:latin typeface="Arial"/>
+                <a:cs typeface="Arial"/>
+              </a:rPr>
+              <a:t>Yue Zhuo</a:t>
+            </a:r>
+            <a:r>
+              <a:rPr lang="en-US" sz="600">
+                <a:solidFill>
+                  <a:srgbClr val="231F20"/>
+                </a:solidFill>
+                <a:latin typeface="Arial"/>
+                <a:cs typeface="Arial"/>
+              </a:rPr>
+              <a:t>, ...</a:t>
             </a:r>
           </a:p>
         </p:txBody>

</xml_diff>

<commit_message>
Conditions slide: four columns with bottom conclusion band; drop internal entry-point note
Co-Authored-By: Claude Opus 5.5 <noreply@anthropic.com>
Claude-Session: https://claude.ai/code/session_01NTagjVHGZdXLvG9VCNzDRT
</commit_message>
<xml_diff>
--- a/slides/Vitoma_why_now_2pages_draft.pptx
+++ b/slides/Vitoma_why_now_2pages_draft.pptx
@@ -1804,8 +1804,8 @@
         </p:nvSpPr>
         <p:spPr>
           <a:xfrm>
-            <a:off x="533400" y="1381125"/>
-            <a:ext cx="3219450" cy="2390775"/>
+            <a:off x="530352" y="1380744"/>
+            <a:ext cx="2610612" cy="2390775"/>
           </a:xfrm>
           <a:custGeom>
             <a:avLst/>
@@ -1850,8 +1850,8 @@
         </p:nvSpPr>
         <p:spPr>
           <a:xfrm>
-            <a:off x="723900" y="1581150"/>
-            <a:ext cx="2838450" cy="257175"/>
+            <a:off x="722376" y="1581912"/>
+            <a:ext cx="2290572" cy="257175"/>
           </a:xfrm>
           <a:prstGeom prst="rect">
             <a:avLst/>
@@ -1899,8 +1899,8 @@
         </p:nvSpPr>
         <p:spPr>
           <a:xfrm>
-            <a:off x="723900" y="1933575"/>
-            <a:ext cx="2838450" cy="876300"/>
+            <a:off x="722376" y="1965960"/>
+            <a:ext cx="2290572" cy="1737360"/>
           </a:xfrm>
           <a:prstGeom prst="rect">
             <a:avLst/>
@@ -1950,8 +1950,8 @@
         </p:nvSpPr>
         <p:spPr>
           <a:xfrm>
-            <a:off x="3886200" y="1381125"/>
-            <a:ext cx="3219450" cy="2390775"/>
+            <a:off x="3369564" y="1380744"/>
+            <a:ext cx="2610612" cy="2390775"/>
           </a:xfrm>
           <a:custGeom>
             <a:avLst/>
@@ -1996,8 +1996,8 @@
         </p:nvSpPr>
         <p:spPr>
           <a:xfrm>
-            <a:off x="4076700" y="1581150"/>
-            <a:ext cx="2838450" cy="257175"/>
+            <a:off x="3561588" y="1581912"/>
+            <a:ext cx="2290572" cy="257175"/>
           </a:xfrm>
           <a:prstGeom prst="rect">
             <a:avLst/>
@@ -2045,8 +2045,8 @@
         </p:nvSpPr>
         <p:spPr>
           <a:xfrm>
-            <a:off x="4076700" y="1933575"/>
-            <a:ext cx="2838450" cy="876300"/>
+            <a:off x="3561588" y="1965960"/>
+            <a:ext cx="2290572" cy="1737360"/>
           </a:xfrm>
           <a:prstGeom prst="rect">
             <a:avLst/>
@@ -2118,8 +2118,8 @@
         </p:nvSpPr>
         <p:spPr>
           <a:xfrm>
-            <a:off x="533400" y="3876675"/>
-            <a:ext cx="3219450" cy="2390775"/>
+            <a:off x="6208776" y="1380744"/>
+            <a:ext cx="2610612" cy="2390775"/>
           </a:xfrm>
           <a:custGeom>
             <a:avLst/>
@@ -2164,8 +2164,8 @@
         </p:nvSpPr>
         <p:spPr>
           <a:xfrm>
-            <a:off x="723900" y="4076700"/>
-            <a:ext cx="2838450" cy="257175"/>
+            <a:off x="6400800" y="1581912"/>
+            <a:ext cx="2290572" cy="257175"/>
           </a:xfrm>
           <a:prstGeom prst="rect">
             <a:avLst/>
@@ -2213,8 +2213,8 @@
         </p:nvSpPr>
         <p:spPr>
           <a:xfrm>
-            <a:off x="723900" y="4429125"/>
-            <a:ext cx="2838450" cy="876300"/>
+            <a:off x="6400800" y="1965960"/>
+            <a:ext cx="2290572" cy="1737360"/>
           </a:xfrm>
           <a:prstGeom prst="rect">
             <a:avLst/>
@@ -2341,8 +2341,8 @@
         </p:nvSpPr>
         <p:spPr>
           <a:xfrm>
-            <a:off x="3886200" y="3876675"/>
-            <a:ext cx="3219450" cy="2390775"/>
+            <a:off x="9047988" y="1380744"/>
+            <a:ext cx="2610612" cy="2390775"/>
           </a:xfrm>
           <a:custGeom>
             <a:avLst/>
@@ -2387,8 +2387,8 @@
         </p:nvSpPr>
         <p:spPr>
           <a:xfrm>
-            <a:off x="4076700" y="4076700"/>
-            <a:ext cx="2838450" cy="257175"/>
+            <a:off x="9240012" y="1581912"/>
+            <a:ext cx="2290572" cy="257175"/>
           </a:xfrm>
           <a:prstGeom prst="rect">
             <a:avLst/>
@@ -2447,8 +2447,8 @@
         </p:nvSpPr>
         <p:spPr>
           <a:xfrm>
-            <a:off x="4076700" y="4429125"/>
-            <a:ext cx="2838450" cy="1127914"/>
+            <a:off x="9240012" y="1965960"/>
+            <a:ext cx="2290572" cy="1737360"/>
           </a:xfrm>
           <a:prstGeom prst="rect">
             <a:avLst/>
@@ -2553,8 +2553,8 @@
         </p:nvSpPr>
         <p:spPr>
           <a:xfrm>
-            <a:off x="7239000" y="1375859"/>
-            <a:ext cx="4286250" cy="4891591"/>
+            <a:off x="530352" y="4114800"/>
+            <a:ext cx="11128248" cy="1783080"/>
           </a:xfrm>
           <a:prstGeom prst="rect">
             <a:avLst/>
@@ -2579,8 +2579,8 @@
         </p:nvSpPr>
         <p:spPr>
           <a:xfrm>
-            <a:off x="7562850" y="1920875"/>
-            <a:ext cx="3752850" cy="257175"/>
+            <a:off x="868680" y="4343400"/>
+            <a:ext cx="10424160" cy="257175"/>
           </a:xfrm>
           <a:prstGeom prst="rect">
             <a:avLst/>
@@ -2605,7 +2605,7 @@
                 <a:ea typeface="微软雅黑"/>
                 <a:cs typeface="微软雅黑"/>
               </a:rPr>
-              <a:t>时机已到，证据已在</a:t>
+              <a:t>四项条件首次同时具备</a:t>
             </a:r>
             <a:r>
               <a:rPr sz="1650" b="1">
@@ -2642,283 +2642,6 @@
       </p:sp>
       <p:sp>
         <p:nvSpPr>
-          <p:cNvPr id="364" name="文本框 298"/>
-          <p:cNvSpPr>
-            <a:spLocks noGrp="1"/>
-          </p:cNvSpPr>
-          <p:nvPr/>
-        </p:nvSpPr>
-        <p:spPr>
-          <a:xfrm>
-            <a:off x="7562850" y="2330450"/>
-            <a:ext cx="3752850" cy="285750"/>
-          </a:xfrm>
-          <a:prstGeom prst="rect">
-            <a:avLst/>
-          </a:prstGeom>
-        </p:spPr>
-        <p:txBody>
-          <a:bodyPr wrap="none" lIns="0" tIns="0" rIns="0" bIns="0"/>
-          <a:lstStyle/>
-          <a:p>
-            <a:pPr>
-              <a:lnSpc>
-                <a:spcPct val="145000"/>
-              </a:lnSpc>
-              <a:buNone/>
-            </a:pPr>
-            <a:r>
-              <a:rPr sz="1275">
-                <a:solidFill>
-                  <a:srgbClr val="99BDED"/>
-                </a:solidFill>
-                <a:latin typeface="微软雅黑"/>
-                <a:ea typeface="微软雅黑"/>
-                <a:cs typeface="微软雅黑"/>
-              </a:rPr>
-              <a:t>· 四项技术条件同步成熟（左）</a:t>
-            </a:r>
-            <a:r>
-              <a:rPr sz="1275">
-                <a:solidFill>
-                  <a:srgbClr val="99BDED"/>
-                </a:solidFill>
-                <a:latin typeface="微软雅黑"/>
-                <a:ea typeface="微软雅黑"/>
-                <a:cs typeface="微软雅黑"/>
-              </a:rPr>
-              <a:t/>
-            </a:r>
-            <a:r>
-              <a:rPr sz="1275">
-                <a:solidFill>
-                  <a:srgbClr val="99BDED"/>
-                </a:solidFill>
-                <a:latin typeface="微软雅黑"/>
-                <a:ea typeface="微软雅黑"/>
-                <a:cs typeface="微软雅黑"/>
-              </a:rPr>
-              <a:t/>
-            </a:r>
-            <a:r>
-              <a:rPr sz="1275">
-                <a:solidFill>
-                  <a:srgbClr val="99BDED"/>
-                </a:solidFill>
-                <a:latin typeface="微软雅黑"/>
-                <a:ea typeface="微软雅黑"/>
-                <a:cs typeface="微软雅黑"/>
-              </a:rPr>
-              <a:t/>
-            </a:r>
-            <a:endParaRPr sz="1275">
-              <a:solidFill>
-                <a:srgbClr val="99BDED"/>
-              </a:solidFill>
-              <a:latin typeface="微软雅黑"/>
-              <a:ea typeface="微软雅黑"/>
-              <a:cs typeface="微软雅黑"/>
-            </a:endParaRPr>
-          </a:p>
-        </p:txBody>
-      </p:sp>
-      <p:sp>
-        <p:nvSpPr>
-          <p:cNvPr id="365" name="文本框 299"/>
-          <p:cNvSpPr>
-            <a:spLocks noGrp="1"/>
-          </p:cNvSpPr>
-          <p:nvPr/>
-        </p:nvSpPr>
-        <p:spPr>
-          <a:xfrm>
-            <a:off x="7562850" y="2711450"/>
-            <a:ext cx="3752850" cy="285750"/>
-          </a:xfrm>
-          <a:prstGeom prst="rect">
-            <a:avLst/>
-          </a:prstGeom>
-        </p:spPr>
-        <p:txBody>
-          <a:bodyPr wrap="none" lIns="0" tIns="0" rIns="0" bIns="0"/>
-          <a:lstStyle/>
-          <a:p>
-            <a:pPr>
-              <a:lnSpc>
-                <a:spcPct val="145000"/>
-              </a:lnSpc>
-              <a:buNone/>
-            </a:pPr>
-            <a:r>
-              <a:rPr sz="1275">
-                <a:solidFill>
-                  <a:srgbClr val="99BDED"/>
-                </a:solidFill>
-                <a:latin typeface="微软雅黑"/>
-                <a:ea typeface="微软雅黑"/>
-                <a:cs typeface="微软雅黑"/>
-              </a:rPr>
-              <a:t>· 类器官预测治疗响应，已获临床研究证实（下页）</a:t>
-            </a:r>
-            <a:r>
-              <a:rPr sz="1275">
-                <a:solidFill>
-                  <a:srgbClr val="99BDED"/>
-                </a:solidFill>
-                <a:latin typeface="微软雅黑"/>
-                <a:ea typeface="微软雅黑"/>
-                <a:cs typeface="微软雅黑"/>
-              </a:rPr>
-              <a:t/>
-            </a:r>
-            <a:endParaRPr sz="1275">
-              <a:solidFill>
-                <a:srgbClr val="99BDED"/>
-              </a:solidFill>
-              <a:latin typeface="微软雅黑"/>
-              <a:ea typeface="微软雅黑"/>
-              <a:cs typeface="微软雅黑"/>
-            </a:endParaRPr>
-          </a:p>
-        </p:txBody>
-      </p:sp>
-      <p:sp>
-        <p:nvSpPr>
-          <p:cNvPr id="366" name="文本框 300"/>
-          <p:cNvSpPr>
-            <a:spLocks noGrp="1"/>
-          </p:cNvSpPr>
-          <p:nvPr/>
-        </p:nvSpPr>
-        <p:spPr>
-          <a:xfrm>
-            <a:off x="7562850" y="3092450"/>
-            <a:ext cx="3752850" cy="285750"/>
-          </a:xfrm>
-          <a:prstGeom prst="rect">
-            <a:avLst/>
-          </a:prstGeom>
-        </p:spPr>
-        <p:txBody>
-          <a:bodyPr wrap="none" lIns="0" tIns="0" rIns="0" bIns="0"/>
-          <a:lstStyle/>
-          <a:p>
-            <a:pPr>
-              <a:lnSpc>
-                <a:spcPct val="145000"/>
-              </a:lnSpc>
-              <a:buNone/>
-            </a:pPr>
-            <a:r>
-              <a:rPr sz="1275">
-                <a:solidFill>
-                  <a:srgbClr val="99BDED"/>
-                </a:solidFill>
-                <a:latin typeface="微软雅黑"/>
-                <a:ea typeface="微软雅黑"/>
-                <a:cs typeface="微软雅黑"/>
-              </a:rPr>
-              <a:t>· 证据来自不同研究团队，并非单一个案</a:t>
-            </a:r>
-            <a:r>
-              <a:rPr sz="1275">
-                <a:solidFill>
-                  <a:srgbClr val="99BDED"/>
-                </a:solidFill>
-                <a:latin typeface="微软雅黑"/>
-                <a:ea typeface="微软雅黑"/>
-                <a:cs typeface="微软雅黑"/>
-              </a:rPr>
-              <a:t/>
-            </a:r>
-            <a:endParaRPr sz="1275">
-              <a:solidFill>
-                <a:srgbClr val="99BDED"/>
-              </a:solidFill>
-              <a:latin typeface="微软雅黑"/>
-              <a:ea typeface="微软雅黑"/>
-              <a:cs typeface="微软雅黑"/>
-            </a:endParaRPr>
-          </a:p>
-        </p:txBody>
-      </p:sp>
-      <p:sp>
-        <p:nvSpPr>
-          <p:cNvPr id="367" name="矩形 301"/>
-          <p:cNvSpPr>
-            <a:spLocks noGrp="1"/>
-          </p:cNvSpPr>
-          <p:nvPr/>
-        </p:nvSpPr>
-        <p:spPr>
-          <a:xfrm>
-            <a:off x="7639050" y="3611880"/>
-            <a:ext cx="3752850" cy="9525"/>
-          </a:xfrm>
-          <a:prstGeom prst="rect">
-            <a:avLst/>
-          </a:prstGeom>
-          <a:solidFill>
-            <a:srgbClr val="44546A"/>
-          </a:solidFill>
-        </p:spPr>
-        <p:txBody>
-          <a:bodyPr/>
-          <a:lstStyle/>
-          <a:p/>
-        </p:txBody>
-      </p:sp>
-      <p:sp>
-        <p:nvSpPr>
-          <p:cNvPr id="368" name="文本框 302"/>
-          <p:cNvSpPr>
-            <a:spLocks noGrp="1"/>
-          </p:cNvSpPr>
-          <p:nvPr/>
-        </p:nvSpPr>
-        <p:spPr>
-          <a:xfrm>
-            <a:off x="7562850" y="3768725"/>
-            <a:ext cx="3752850" cy="228600"/>
-          </a:xfrm>
-          <a:prstGeom prst="rect">
-            <a:avLst/>
-          </a:prstGeom>
-        </p:spPr>
-        <p:txBody>
-          <a:bodyPr wrap="none" lIns="0" tIns="0" rIns="0" bIns="0"/>
-          <a:lstStyle/>
-          <a:p>
-            <a:pPr>
-              <a:lnSpc>
-                <a:spcPct val="100000"/>
-              </a:lnSpc>
-              <a:buNone/>
-            </a:pPr>
-            <a:r>
-              <a:rPr sz="1500" b="1">
-                <a:solidFill>
-                  <a:srgbClr val="08A6F6"/>
-                </a:solidFill>
-                <a:latin typeface="微软雅黑"/>
-                <a:ea typeface="微软雅黑"/>
-                <a:cs typeface="微软雅黑"/>
-              </a:rPr>
-              <a:t>我们的切入点</a:t>
-            </a:r>
-            <a:endParaRPr sz="1500" b="1">
-              <a:solidFill>
-                <a:srgbClr val="08A6F6"/>
-              </a:solidFill>
-              <a:latin typeface="微软雅黑"/>
-              <a:ea typeface="微软雅黑"/>
-              <a:cs typeface="微软雅黑"/>
-            </a:endParaRPr>
-          </a:p>
-        </p:txBody>
-      </p:sp>
-      <p:sp>
-        <p:nvSpPr>
           <p:cNvPr id="369" name="文本框 303"/>
           <p:cNvSpPr>
             <a:spLocks noGrp="1"/>
@@ -2927,8 +2650,8 @@
         </p:nvSpPr>
         <p:spPr>
           <a:xfrm>
-            <a:off x="7562850" y="4111625"/>
-            <a:ext cx="3752850" cy="1079500"/>
+            <a:off x="868680" y="4727448"/>
+            <a:ext cx="10424160" cy="822960"/>
           </a:xfrm>
           <a:prstGeom prst="rect">
             <a:avLst/>
@@ -2967,7 +2690,7 @@
                 <a:ea typeface="微软雅黑"/>
                 <a:cs typeface="微软雅黑"/>
               </a:rPr>
-              <a:t>先从临床路径更标准化的实体瘤切入，更快做出可验证的成果、覆盖更广的应用；再拓展到复杂度最高的脑肿瘤。</a:t>
+              <a:t>患者来源类器官能保留个体肿瘤特征，多模态测量能把细胞状态变成可计算的数据，算力与 AI 方法能学习「干预后进入什么新状态」——患者特异性的治疗响应与复发预测，第一次从科学设想进入工程可行阶段。</a:t>
             </a:r>
             <a:endParaRPr sz="1275">
               <a:solidFill>
@@ -2992,8 +2715,8 @@
         </p:nvSpPr>
         <p:spPr>
           <a:xfrm>
-            <a:off x="7562850" y="5305425"/>
-            <a:ext cx="3752850" cy="304800"/>
+            <a:off x="868680" y="5440680"/>
+            <a:ext cx="10424160" cy="304800"/>
           </a:xfrm>
           <a:prstGeom prst="rect">
             <a:avLst/>
@@ -3020,7 +2743,7 @@
                 <a:ea typeface="微软雅黑"/>
                 <a:cs typeface="微软雅黑"/>
               </a:rPr>
-              <a:t>→ 下一页：临床研究证据</a:t>
+              <a:t>→ 临床证据：类器官已在前瞻性研究中预测患者治疗响应（见下页）</a:t>
             </a:r>
             <a:endParaRPr sz="1275" b="1">
               <a:solidFill>

</xml_diff>

<commit_message>
Evidence slide: Cell Stem Cell (predicts) + Nature 2026 HCMI (fidelity) with full source notes
Co-Authored-By: Claude Opus 5.5 <noreply@anthropic.com>
Claude-Session: https://claude.ai/code/session_01NTagjVHGZdXLvG9VCNzDRT
</commit_message>
<xml_diff>
--- a/slides/Vitoma_why_now_2pages_draft.pptx
+++ b/slides/Vitoma_why_now_2pages_draft.pptx
@@ -752,7 +752,7 @@
                 <a:ea typeface="微软雅黑"/>
                 <a:cs typeface="微软雅黑"/>
               </a:rPr>
-              <a:t>为什么是现在：类器官预测患者治疗响应，已获独立研究证实</a:t>
+              <a:t>为什么是现在：类器官「能预测」也「保真」，已获多项研究证实</a:t>
             </a:r>
             <a:endParaRPr sz="2475" b="1">
               <a:solidFill>
@@ -967,6 +967,9 @@
             <a:avLst/>
           </a:prstGeom>
           <a:noFill/>
+          <a:ln>
+            <a:noFill/>
+          </a:ln>
         </p:spPr>
         <p:txBody>
           <a:bodyPr wrap="square" lIns="0" tIns="0" rIns="0" bIns="0" anchor="t">
@@ -976,7 +979,7 @@
           <a:p>
             <a:pPr algn="l">
               <a:lnSpc>
-                <a:spcPct val="120000"/>
+                <a:spcPct val="115000"/>
               </a:lnSpc>
               <a:buNone/>
             </a:pPr>
@@ -989,7 +992,7 @@
                 <a:ea typeface="微软雅黑"/>
                 <a:cs typeface="微软雅黑"/>
               </a:rPr>
-              <a:t>证据 1｜Peng et al., </a:t>
+              <a:t>证据 1｜能预测｜Peng et al., </a:t>
             </a:r>
             <a:r>
               <a:rPr lang="zh-CN" altLang="en-US" sz="1100" b="1" i="1">
@@ -1017,7 +1020,7 @@
           <a:p>
             <a:pPr algn="l">
               <a:lnSpc>
-                <a:spcPct val="120000"/>
+                <a:spcPct val="115000"/>
               </a:lnSpc>
               <a:buNone/>
             </a:pPr>
@@ -1037,7 +1040,7 @@
       </p:sp>
       <p:sp>
         <p:nvSpPr>
-          <p:cNvPr id="402" name="证据2图片占位"/>
+          <p:cNvPr id="402" name="证据2边框"/>
           <p:cNvSpPr txBox="1"/>
           <p:nvPr/>
         </p:nvSpPr>
@@ -1050,13 +1053,333 @@
             <a:avLst/>
           </a:prstGeom>
           <a:solidFill>
-            <a:srgbClr val="F2F5F9"/>
+            <a:srgbClr val="FFFFFF"/>
           </a:solidFill>
           <a:ln w="9525">
             <a:solidFill>
-              <a:srgbClr val="99BDED"/>
+              <a:srgbClr val="D9D9D9"/>
             </a:solidFill>
-            <a:prstDash val="dash"/>
+          </a:ln>
+        </p:spPr>
+        <p:txBody>
+          <a:bodyPr wrap="square" lIns="0" tIns="0" rIns="0" bIns="0" anchor="t">
+            <a:noAutofit/>
+          </a:bodyPr>
+          <a:lstStyle/>
+          <a:p/>
+        </p:txBody>
+      </p:sp>
+      <p:pic>
+        <p:nvPicPr>
+          <p:cNvPr id="403" name="证据2图片" descr="Nature 2026 HCMI 论文标题与作者"/>
+          <p:cNvPicPr>
+            <a:picLocks noChangeAspect="1"/>
+          </p:cNvPicPr>
+          <p:nvPr/>
+        </p:nvPicPr>
+        <p:blipFill>
+          <a:blip r:embed="rId9"/>
+          <a:stretch>
+            <a:fillRect/>
+          </a:stretch>
+        </p:blipFill>
+        <p:spPr>
+          <a:xfrm>
+            <a:off x="4818888" y="1078992"/>
+            <a:ext cx="3877056" cy="1930774"/>
+          </a:xfrm>
+          <a:prstGeom prst="rect">
+            <a:avLst/>
+          </a:prstGeom>
+        </p:spPr>
+      </p:pic>
+      <p:sp>
+        <p:nvSpPr>
+          <p:cNvPr id="404" name="证据2数字1"/>
+          <p:cNvSpPr txBox="1"/>
+          <p:nvPr/>
+        </p:nvSpPr>
+        <p:spPr>
+          <a:xfrm>
+            <a:off x="4892040" y="3337560"/>
+            <a:ext cx="1243584" cy="548640"/>
+          </a:xfrm>
+          <a:prstGeom prst="rect">
+            <a:avLst/>
+          </a:prstGeom>
+          <a:noFill/>
+          <a:ln>
+            <a:noFill/>
+          </a:ln>
+        </p:spPr>
+        <p:txBody>
+          <a:bodyPr wrap="square" lIns="0" tIns="0" rIns="0" bIns="0" anchor="b">
+            <a:noAutofit/>
+          </a:bodyPr>
+          <a:lstStyle/>
+          <a:p>
+            <a:pPr algn="ctr">
+              <a:lnSpc>
+                <a:spcPct val="115000"/>
+              </a:lnSpc>
+              <a:buNone/>
+            </a:pPr>
+            <a:r>
+              <a:rPr lang="zh-CN" altLang="en-US" sz="2600" b="1">
+                <a:solidFill>
+                  <a:srgbClr val="061F32"/>
+                </a:solidFill>
+                <a:latin typeface="微软雅黑"/>
+                <a:ea typeface="微软雅黑"/>
+                <a:cs typeface="微软雅黑"/>
+              </a:rPr>
+              <a:t>665</a:t>
+            </a:r>
+          </a:p>
+        </p:txBody>
+      </p:sp>
+      <p:sp>
+        <p:nvSpPr>
+          <p:cNvPr id="405" name="证据2标签1"/>
+          <p:cNvSpPr txBox="1"/>
+          <p:nvPr/>
+        </p:nvSpPr>
+        <p:spPr>
+          <a:xfrm>
+            <a:off x="4892040" y="3913632"/>
+            <a:ext cx="1243584" cy="274320"/>
+          </a:xfrm>
+          <a:prstGeom prst="rect">
+            <a:avLst/>
+          </a:prstGeom>
+          <a:noFill/>
+          <a:ln>
+            <a:noFill/>
+          </a:ln>
+        </p:spPr>
+        <p:txBody>
+          <a:bodyPr wrap="square" lIns="0" tIns="0" rIns="0" bIns="0" anchor="t">
+            <a:noAutofit/>
+          </a:bodyPr>
+          <a:lstStyle/>
+          <a:p>
+            <a:pPr algn="ctr">
+              <a:lnSpc>
+                <a:spcPct val="115000"/>
+              </a:lnSpc>
+              <a:buNone/>
+            </a:pPr>
+            <a:r>
+              <a:rPr lang="zh-CN" altLang="en-US" sz="1000">
+                <a:solidFill>
+                  <a:srgbClr val="44546A"/>
+                </a:solidFill>
+                <a:latin typeface="微软雅黑"/>
+                <a:ea typeface="微软雅黑"/>
+                <a:cs typeface="微软雅黑"/>
+              </a:rPr>
+              <a:t>个患者来源模型</a:t>
+            </a:r>
+          </a:p>
+        </p:txBody>
+      </p:sp>
+      <p:sp>
+        <p:nvSpPr>
+          <p:cNvPr id="406" name="证据2数字2"/>
+          <p:cNvSpPr txBox="1"/>
+          <p:nvPr/>
+        </p:nvSpPr>
+        <p:spPr>
+          <a:xfrm>
+            <a:off x="6135624" y="3337560"/>
+            <a:ext cx="1243584" cy="548640"/>
+          </a:xfrm>
+          <a:prstGeom prst="rect">
+            <a:avLst/>
+          </a:prstGeom>
+          <a:noFill/>
+          <a:ln>
+            <a:noFill/>
+          </a:ln>
+        </p:spPr>
+        <p:txBody>
+          <a:bodyPr wrap="square" lIns="0" tIns="0" rIns="0" bIns="0" anchor="b">
+            <a:noAutofit/>
+          </a:bodyPr>
+          <a:lstStyle/>
+          <a:p>
+            <a:pPr algn="ctr">
+              <a:lnSpc>
+                <a:spcPct val="115000"/>
+              </a:lnSpc>
+              <a:buNone/>
+            </a:pPr>
+            <a:r>
+              <a:rPr lang="zh-CN" altLang="en-US" sz="2600" b="1">
+                <a:solidFill>
+                  <a:srgbClr val="061F32"/>
+                </a:solidFill>
+                <a:latin typeface="微软雅黑"/>
+                <a:ea typeface="微软雅黑"/>
+                <a:cs typeface="微软雅黑"/>
+              </a:rPr>
+              <a:t>25</a:t>
+            </a:r>
+          </a:p>
+        </p:txBody>
+      </p:sp>
+      <p:sp>
+        <p:nvSpPr>
+          <p:cNvPr id="407" name="证据2标签2"/>
+          <p:cNvSpPr txBox="1"/>
+          <p:nvPr/>
+        </p:nvSpPr>
+        <p:spPr>
+          <a:xfrm>
+            <a:off x="6135624" y="3913632"/>
+            <a:ext cx="1243584" cy="274320"/>
+          </a:xfrm>
+          <a:prstGeom prst="rect">
+            <a:avLst/>
+          </a:prstGeom>
+          <a:noFill/>
+          <a:ln>
+            <a:noFill/>
+          </a:ln>
+        </p:spPr>
+        <p:txBody>
+          <a:bodyPr wrap="square" lIns="0" tIns="0" rIns="0" bIns="0" anchor="t">
+            <a:noAutofit/>
+          </a:bodyPr>
+          <a:lstStyle/>
+          <a:p>
+            <a:pPr algn="ctr">
+              <a:lnSpc>
+                <a:spcPct val="115000"/>
+              </a:lnSpc>
+              <a:buNone/>
+            </a:pPr>
+            <a:r>
+              <a:rPr lang="zh-CN" altLang="en-US" sz="1000">
+                <a:solidFill>
+                  <a:srgbClr val="44546A"/>
+                </a:solidFill>
+                <a:latin typeface="微软雅黑"/>
+                <a:ea typeface="微软雅黑"/>
+                <a:cs typeface="微软雅黑"/>
+              </a:rPr>
+              <a:t>种癌症</a:t>
+            </a:r>
+          </a:p>
+        </p:txBody>
+      </p:sp>
+      <p:sp>
+        <p:nvSpPr>
+          <p:cNvPr id="408" name="证据2数字3"/>
+          <p:cNvSpPr txBox="1"/>
+          <p:nvPr/>
+        </p:nvSpPr>
+        <p:spPr>
+          <a:xfrm>
+            <a:off x="7379208" y="3337560"/>
+            <a:ext cx="1243584" cy="548640"/>
+          </a:xfrm>
+          <a:prstGeom prst="rect">
+            <a:avLst/>
+          </a:prstGeom>
+          <a:noFill/>
+          <a:ln>
+            <a:noFill/>
+          </a:ln>
+        </p:spPr>
+        <p:txBody>
+          <a:bodyPr wrap="square" lIns="0" tIns="0" rIns="0" bIns="0" anchor="b">
+            <a:noAutofit/>
+          </a:bodyPr>
+          <a:lstStyle/>
+          <a:p>
+            <a:pPr algn="ctr">
+              <a:lnSpc>
+                <a:spcPct val="115000"/>
+              </a:lnSpc>
+              <a:buNone/>
+            </a:pPr>
+            <a:r>
+              <a:rPr lang="zh-CN" altLang="en-US" sz="2600" b="1">
+                <a:solidFill>
+                  <a:srgbClr val="061F32"/>
+                </a:solidFill>
+                <a:latin typeface="微软雅黑"/>
+                <a:ea typeface="微软雅黑"/>
+                <a:cs typeface="微软雅黑"/>
+              </a:rPr>
+              <a:t>97.8%</a:t>
+            </a:r>
+          </a:p>
+        </p:txBody>
+      </p:sp>
+      <p:sp>
+        <p:nvSpPr>
+          <p:cNvPr id="409" name="证据2标签3"/>
+          <p:cNvSpPr txBox="1"/>
+          <p:nvPr/>
+        </p:nvSpPr>
+        <p:spPr>
+          <a:xfrm>
+            <a:off x="7379208" y="3913632"/>
+            <a:ext cx="1243584" cy="274320"/>
+          </a:xfrm>
+          <a:prstGeom prst="rect">
+            <a:avLst/>
+          </a:prstGeom>
+          <a:noFill/>
+          <a:ln>
+            <a:noFill/>
+          </a:ln>
+        </p:spPr>
+        <p:txBody>
+          <a:bodyPr wrap="square" lIns="0" tIns="0" rIns="0" bIns="0" anchor="t">
+            <a:noAutofit/>
+          </a:bodyPr>
+          <a:lstStyle/>
+          <a:p>
+            <a:pPr algn="ctr">
+              <a:lnSpc>
+                <a:spcPct val="115000"/>
+              </a:lnSpc>
+              <a:buNone/>
+            </a:pPr>
+            <a:r>
+              <a:rPr lang="zh-CN" altLang="en-US" sz="1000">
+                <a:solidFill>
+                  <a:srgbClr val="44546A"/>
+                </a:solidFill>
+                <a:latin typeface="微软雅黑"/>
+                <a:ea typeface="微软雅黑"/>
+                <a:cs typeface="微软雅黑"/>
+              </a:rPr>
+              <a:t>DNA 特征一致性</a:t>
+            </a:r>
+          </a:p>
+        </p:txBody>
+      </p:sp>
+      <p:sp>
+        <p:nvSpPr>
+          <p:cNvPr id="410" name="证据2补充"/>
+          <p:cNvSpPr txBox="1"/>
+          <p:nvPr/>
+        </p:nvSpPr>
+        <p:spPr>
+          <a:xfrm>
+            <a:off x="4937760" y="4343400"/>
+            <a:ext cx="3639312" cy="868680"/>
+          </a:xfrm>
+          <a:prstGeom prst="rect">
+            <a:avLst/>
+          </a:prstGeom>
+          <a:noFill/>
+          <a:ln>
+            <a:noFill/>
           </a:ln>
         </p:spPr>
         <p:txBody>
@@ -1067,49 +1390,27 @@
           <a:p>
             <a:pPr algn="ctr">
               <a:lnSpc>
-                <a:spcPct val="120000"/>
-              </a:lnSpc>
-              <a:spcAft>
-                <a:spcPts val="300"/>
-              </a:spcAft>
-              <a:buNone/>
-            </a:pPr>
-            <a:r>
-              <a:rPr lang="zh-CN" altLang="en-US" sz="1400" b="1">
-                <a:solidFill>
-                  <a:srgbClr val="8496B0"/>
-                </a:solidFill>
-                <a:latin typeface="微软雅黑"/>
-                <a:ea typeface="微软雅黑"/>
-                <a:cs typeface="微软雅黑"/>
-              </a:rPr>
-              <a:t>证据 2 配图</a:t>
-            </a:r>
-          </a:p>
-          <a:p>
-            <a:pPr algn="ctr">
-              <a:lnSpc>
-                <a:spcPct val="120000"/>
+                <a:spcPct val="115000"/>
               </a:lnSpc>
               <a:buNone/>
             </a:pPr>
             <a:r>
-              <a:rPr lang="zh-CN" altLang="en-US" sz="1100">
-                <a:solidFill>
-                  <a:srgbClr val="8496B0"/>
-                </a:solidFill>
-                <a:latin typeface="微软雅黑"/>
-                <a:ea typeface="微软雅黑"/>
-                <a:cs typeface="微软雅黑"/>
-              </a:rPr>
-              <a:t>待放入微信文章中论文的关键图</a:t>
+              <a:rPr lang="zh-CN" altLang="en-US" sz="1000">
+                <a:solidFill>
+                  <a:srgbClr val="44546A"/>
+                </a:solidFill>
+                <a:latin typeface="微软雅黑"/>
+                <a:ea typeface="微软雅黑"/>
+                <a:cs typeface="微软雅黑"/>
+              </a:rPr>
+              <a:t>421 对「肿瘤–模型」配对：DNA 甲基化一致性 95%，转录组吻合 92%；覆盖结直肠、胰腺、食管及罕见癌种</a:t>
             </a:r>
           </a:p>
         </p:txBody>
       </p:sp>
       <p:sp>
         <p:nvSpPr>
-          <p:cNvPr id="403" name="证据2说明"/>
+          <p:cNvPr id="411" name="证据2说明"/>
           <p:cNvSpPr txBox="1"/>
           <p:nvPr/>
         </p:nvSpPr>
@@ -1122,6 +1423,9 @@
             <a:avLst/>
           </a:prstGeom>
           <a:noFill/>
+          <a:ln>
+            <a:noFill/>
+          </a:ln>
         </p:spPr>
         <p:txBody>
           <a:bodyPr wrap="square" lIns="0" tIns="0" rIns="0" bIns="0" anchor="t">
@@ -1131,7 +1435,7 @@
           <a:p>
             <a:pPr algn="l">
               <a:lnSpc>
-                <a:spcPct val="120000"/>
+                <a:spcPct val="115000"/>
               </a:lnSpc>
               <a:buNone/>
             </a:pPr>
@@ -1144,13 +1448,35 @@
                 <a:ea typeface="微软雅黑"/>
                 <a:cs typeface="微软雅黑"/>
               </a:rPr>
-              <a:t>证据 2｜（论文作者、期刊、年份待补充）</a:t>
+              <a:t>证据 2｜能保真｜ElHarouni et al., </a:t>
+            </a:r>
+            <a:r>
+              <a:rPr lang="zh-CN" altLang="en-US" sz="1100" b="1" i="1">
+                <a:solidFill>
+                  <a:srgbClr val="061F32"/>
+                </a:solidFill>
+                <a:latin typeface="微软雅黑"/>
+                <a:ea typeface="微软雅黑"/>
+                <a:cs typeface="微软雅黑"/>
+              </a:rPr>
+              <a:t>Nature</a:t>
+            </a:r>
+            <a:r>
+              <a:rPr lang="zh-CN" altLang="en-US" sz="1100" b="1">
+                <a:solidFill>
+                  <a:srgbClr val="061F32"/>
+                </a:solidFill>
+                <a:latin typeface="微软雅黑"/>
+                <a:ea typeface="微软雅黑"/>
+                <a:cs typeface="微软雅黑"/>
+              </a:rPr>
+              <a:t> 2026</a:t>
             </a:r>
           </a:p>
           <a:p>
             <a:pPr algn="l">
               <a:lnSpc>
-                <a:spcPct val="120000"/>
+                <a:spcPct val="115000"/>
               </a:lnSpc>
               <a:buNone/>
             </a:pPr>
@@ -1163,14 +1489,14 @@
                 <a:ea typeface="微软雅黑"/>
                 <a:cs typeface="微软雅黑"/>
               </a:rPr>
-              <a:t>（一句话结论待补充：该研究在哪个瘤种、用什么方法证明类器官 / AI 可预测患者治疗响应）</a:t>
+              <a:t>人类癌症模型计划（HCMI），Broad 研究所 / 美国国家癌症研究所独立团队；患者来源模型长期传代后仍高度保留原发肿瘤特征</a:t>
             </a:r>
           </a:p>
         </p:txBody>
       </p:sp>
       <p:sp>
         <p:nvSpPr>
-          <p:cNvPr id="404" name="结论面板"/>
+          <p:cNvPr id="412" name="结论面板"/>
           <p:cNvSpPr txBox="1"/>
           <p:nvPr/>
         </p:nvSpPr>
@@ -1185,6 +1511,9 @@
           <a:solidFill>
             <a:srgbClr val="061F32"/>
           </a:solidFill>
+          <a:ln>
+            <a:noFill/>
+          </a:ln>
         </p:spPr>
         <p:txBody>
           <a:bodyPr wrap="square" lIns="201168" tIns="201168" rIns="201168" bIns="201168" anchor="t">
@@ -1194,7 +1523,7 @@
           <a:p>
             <a:pPr algn="l">
               <a:lnSpc>
-                <a:spcPct val="120000"/>
+                <a:spcPct val="115000"/>
               </a:lnSpc>
               <a:spcAft>
                 <a:spcPts val="900"/>
@@ -1216,7 +1545,7 @@
           <a:p>
             <a:pPr algn="l" marL="171450" indent="-171450">
               <a:lnSpc>
-                <a:spcPct val="120000"/>
+                <a:spcPct val="115000"/>
               </a:lnSpc>
               <a:spcAft>
                 <a:spcPts val="900"/>
@@ -1236,7 +1565,7 @@
                 <a:ea typeface="微软雅黑"/>
                 <a:cs typeface="微软雅黑"/>
               </a:rPr>
-              <a:t>不止我们：</a:t>
+              <a:t>能保真：</a:t>
             </a:r>
             <a:r>
               <a:rPr lang="zh-CN" altLang="en-US" sz="1200">
@@ -1247,13 +1576,13 @@
                 <a:ea typeface="微软雅黑"/>
                 <a:cs typeface="微软雅黑"/>
               </a:rPr>
-              <a:t>独立研究团队已在肿瘤治疗领域证明，患者来源类器官可在临床场景中预测治疗响应</a:t>
+              <a:t>独立团队在 25 种癌症中证明，患者来源模型长期传代后仍高度保留原发肿瘤特征</a:t>
             </a:r>
           </a:p>
           <a:p>
             <a:pPr algn="l" marL="171450" indent="-171450">
               <a:lnSpc>
-                <a:spcPct val="120000"/>
+                <a:spcPct val="115000"/>
               </a:lnSpc>
               <a:spcAft>
                 <a:spcPts val="900"/>
@@ -1273,7 +1602,7 @@
                 <a:ea typeface="微软雅黑"/>
                 <a:cs typeface="微软雅黑"/>
               </a:rPr>
-              <a:t>从「能不能」到「怎么规模化」：</a:t>
+              <a:t>能预测：</a:t>
             </a:r>
             <a:r>
               <a:rPr lang="zh-CN" altLang="en-US" sz="1200">
@@ -1284,13 +1613,50 @@
                 <a:ea typeface="微软雅黑"/>
                 <a:cs typeface="微软雅黑"/>
               </a:rPr>
-              <a:t>科学可行性已被验证，下一步是纵向校准与标准化交付</a:t>
+              <a:t>前瞻性研究证明，类器官可在临床中预测患者治疗响应</a:t>
+            </a:r>
+          </a:p>
+          <a:p>
+            <a:pPr algn="l" marL="171450" indent="-171450">
+              <a:lnSpc>
+                <a:spcPct val="115000"/>
+              </a:lnSpc>
+              <a:spcAft>
+                <a:spcPts val="900"/>
+              </a:spcAft>
+              <a:buClr>
+                <a:srgbClr val="08A6F6"/>
+              </a:buClr>
+              <a:buFont typeface="Arial"/>
+              <a:buChar char="•"/>
+            </a:pPr>
+            <a:r>
+              <a:rPr lang="zh-CN" altLang="en-US" sz="1200" b="1">
+                <a:solidFill>
+                  <a:srgbClr val="08A6F6"/>
+                </a:solidFill>
+                <a:latin typeface="微软雅黑"/>
+                <a:ea typeface="微软雅黑"/>
+                <a:cs typeface="微软雅黑"/>
+              </a:rPr>
+              <a:t>下一步：</a:t>
+            </a:r>
+            <a:r>
+              <a:rPr lang="zh-CN" altLang="en-US" sz="1200">
+                <a:solidFill>
+                  <a:srgbClr val="FFFFFF"/>
+                </a:solidFill>
+                <a:latin typeface="微软雅黑"/>
+                <a:ea typeface="微软雅黑"/>
+                <a:cs typeface="微软雅黑"/>
+              </a:rPr>
+              <a:t>从单点验证走向纵向校准与标准化交付</a:t>
             </a:r>
           </a:p>
           <a:p>
             <a:pPr algn="l">
               <a:lnSpc>
-                <a:spcPct val="120000"/>
+                <a:spcPct val="115000"/>
               </a:lnSpc>
               <a:buNone/>
             </a:pPr>
@@ -1319,7 +1685,7 @@
         <p:spPr>
           <a:xfrm>
             <a:off x="533400" y="6381750"/>
-            <a:ext cx="4886325" cy="161925"/>
+            <a:ext cx="10900000" cy="161925"/>
           </a:xfrm>
           <a:prstGeom prst="rect">
             <a:avLst/>
@@ -1344,7 +1710,7 @@
                 <a:ea typeface="微软雅黑"/>
                 <a:cs typeface="微软雅黑"/>
               </a:rPr>
-              <a:t>Source: Peng et al., Cell Stem Cell 32, 652–669 (2025)；证据 2 出处待补充</a:t>
+              <a:t>图片与数据来源：Peng T. et al., Cell Stem Cell 32, 652–669 (2025)；ElHarouni D. et al., Nature (2026), doi:10.1038/s41586-026-10806-y（开放获取）</a:t>
             </a:r>
             <a:r>
               <a:rPr sz="1050">

</xml_diff>

<commit_message>
Evidence slide: precise 'molecular fidelity' wording, corrected metric labels, fidelity-boundary note
Co-Authored-By: Claude Opus 5.5 <noreply@anthropic.com>
Claude-Session: https://claude.ai/code/session_01NTagjVHGZdXLvG9VCNzDRT
</commit_message>
<xml_diff>
--- a/slides/Vitoma_why_now_2pages_draft.pptx
+++ b/slides/Vitoma_why_now_2pages_draft.pptx
@@ -752,7 +752,7 @@
                 <a:ea typeface="微软雅黑"/>
                 <a:cs typeface="微软雅黑"/>
               </a:rPr>
-              <a:t>为什么是现在：类器官「能预测」也「保真」，已获多项研究证实</a:t>
+              <a:t>为什么是现在：类器官分子高保真、能预测治疗响应，已获多项研究证实</a:t>
             </a:r>
             <a:endParaRPr sz="2475" b="1">
               <a:solidFill>
@@ -1327,7 +1327,7 @@
         <p:spPr>
           <a:xfrm>
             <a:off x="7379208" y="3913632"/>
-            <a:ext cx="1243584" cy="274320"/>
+            <a:ext cx="1243584" cy="411480"/>
           </a:xfrm>
           <a:prstGeom prst="rect">
             <a:avLst/>
@@ -1358,7 +1358,7 @@
                 <a:ea typeface="微软雅黑"/>
                 <a:cs typeface="微软雅黑"/>
               </a:rPr>
-              <a:t>DNA 特征一致性</a:t>
+              <a:t>模型保留关键 DNA 特征</a:t>
             </a:r>
           </a:p>
         </p:txBody>
@@ -1403,7 +1403,7 @@
                 <a:ea typeface="微软雅黑"/>
                 <a:cs typeface="微软雅黑"/>
               </a:rPr>
-              <a:t>421 对「肿瘤–模型」配对：DNA 甲基化一致性 95%，转录组吻合 92%；覆盖结直肠、胰腺、食管及罕见癌种</a:t>
+              <a:t>421 对「肿瘤–模型」配对：95% 配对样本甲基化一致，92% 模型转录组吻合；覆盖结直肠、胰腺、食管及罕见癌种</a:t>
             </a:r>
           </a:p>
         </p:txBody>
@@ -1448,7 +1448,7 @@
                 <a:ea typeface="微软雅黑"/>
                 <a:cs typeface="微软雅黑"/>
               </a:rPr>
-              <a:t>证据 2｜能保真｜ElHarouni et al., </a:t>
+              <a:t>证据 2｜分子高保真｜ElHarouni et al., </a:t>
             </a:r>
             <a:r>
               <a:rPr lang="zh-CN" altLang="en-US" sz="1100" b="1" i="1">
@@ -1489,7 +1489,7 @@
                 <a:ea typeface="微软雅黑"/>
                 <a:cs typeface="微软雅黑"/>
               </a:rPr>
-              <a:t>人类癌症模型计划（HCMI），Broad 研究所 / 美国国家癌症研究所独立团队；患者来源模型长期传代后仍高度保留原发肿瘤特征</a:t>
+              <a:t>人类癌症模型计划（HCMI），Broad 研究所 / 美国国家癌症研究所独立团队；患者来源模型长期传代后仍保留原发肿瘤的分子特征</a:t>
             </a:r>
           </a:p>
         </p:txBody>
@@ -1557,7 +1557,7 @@
               <a:buChar char="•"/>
             </a:pPr>
             <a:r>
-              <a:rPr lang="zh-CN" altLang="en-US" sz="1200" b="1">
+              <a:rPr lang="zh-CN" altLang="en-US" sz="1150" b="1">
                 <a:solidFill>
                   <a:srgbClr val="08A6F6"/>
                 </a:solidFill>
@@ -1565,10 +1565,10 @@
                 <a:ea typeface="微软雅黑"/>
                 <a:cs typeface="微软雅黑"/>
               </a:rPr>
-              <a:t>能保真：</a:t>
-            </a:r>
-            <a:r>
-              <a:rPr lang="zh-CN" altLang="en-US" sz="1200">
+              <a:t>分子高保真：</a:t>
+            </a:r>
+            <a:r>
+              <a:rPr lang="zh-CN" altLang="en-US" sz="1150">
                 <a:solidFill>
                   <a:srgbClr val="FFFFFF"/>
                 </a:solidFill>
@@ -1576,7 +1576,7 @@
                 <a:ea typeface="微软雅黑"/>
                 <a:cs typeface="微软雅黑"/>
               </a:rPr>
-              <a:t>独立团队在 25 种癌症中证明，患者来源模型长期传代后仍高度保留原发肿瘤特征</a:t>
+              <a:t>独立团队在 25 种癌症、421 对配对样本中证明，模型长期传代后仍保留原发肿瘤的基因组、甲基化与转录组特征</a:t>
             </a:r>
           </a:p>
           <a:p>
@@ -1594,7 +1594,7 @@
               <a:buChar char="•"/>
             </a:pPr>
             <a:r>
-              <a:rPr lang="zh-CN" altLang="en-US" sz="1200" b="1">
+              <a:rPr lang="zh-CN" altLang="en-US" sz="1150" b="1">
                 <a:solidFill>
                   <a:srgbClr val="08A6F6"/>
                 </a:solidFill>
@@ -1605,7 +1605,7 @@
               <a:t>能预测：</a:t>
             </a:r>
             <a:r>
-              <a:rPr lang="zh-CN" altLang="en-US" sz="1200">
+              <a:rPr lang="zh-CN" altLang="en-US" sz="1150">
                 <a:solidFill>
                   <a:srgbClr val="FFFFFF"/>
                 </a:solidFill>
@@ -1631,7 +1631,7 @@
               <a:buChar char="•"/>
             </a:pPr>
             <a:r>
-              <a:rPr lang="zh-CN" altLang="en-US" sz="1200" b="1">
+              <a:rPr lang="zh-CN" altLang="en-US" sz="1150" b="1">
                 <a:solidFill>
                   <a:srgbClr val="08A6F6"/>
                 </a:solidFill>
@@ -1639,10 +1639,10 @@
                 <a:ea typeface="微软雅黑"/>
                 <a:cs typeface="微软雅黑"/>
               </a:rPr>
-              <a:t>下一步：</a:t>
-            </a:r>
-            <a:r>
-              <a:rPr lang="zh-CN" altLang="en-US" sz="1200">
+              <a:t>保真有边界：</a:t>
+            </a:r>
+            <a:r>
+              <a:rPr lang="zh-CN" altLang="en-US" sz="1150">
                 <a:solidFill>
                   <a:srgbClr val="FFFFFF"/>
                 </a:solidFill>
@@ -1650,7 +1650,7 @@
                 <a:ea typeface="微软雅黑"/>
                 <a:cs typeface="微软雅黑"/>
               </a:rPr>
-              <a:t>从单点验证走向纵向校准与标准化交付</a:t>
+              <a:t>培养会带来可逆的细胞状态漂移，需要系统校准——这正是下一步要补上的</a:t>
             </a:r>
           </a:p>
           <a:p>
@@ -1661,7 +1661,7 @@
               <a:buNone/>
             </a:pPr>
             <a:r>
-              <a:rPr lang="zh-CN" altLang="en-US" sz="1200" b="1">
+              <a:rPr lang="zh-CN" altLang="en-US" sz="1150" b="1">
                 <a:solidFill>
                   <a:srgbClr val="99BDED"/>
                 </a:solidFill>

</xml_diff>